<commit_message>
docs: deck sin rutas locales y aviso de datos sinteticos para repo publico
</commit_message>
<xml_diff>
--- a/docs/FieldOps.pptx
+++ b/docs/FieldOps.pptx
@@ -2359,7 +2359,7 @@
       </p:sp>
       <p:pic>
         <p:nvPicPr>
-          <p:cNvPr id="5" name="Image 0" descr="C:\Users\lucac\Documents\Aplicaciones\fieldops-modernization\docs\capturas\deck\11-busqueda.png">    </p:cNvPr>
+          <p:cNvPr id="5" name="Image 0" descr="11-busqueda.png">    </p:cNvPr>
           <p:cNvPicPr>
             <a:picLocks noChangeAspect="1"/>
           </p:cNvPicPr>
@@ -8323,7 +8323,7 @@
       </p:sp>
       <p:pic>
         <p:nvPicPr>
-          <p:cNvPr id="5" name="Image 0" descr="C:\Users\lucac\Documents\Aplicaciones\fieldops-modernization\docs\capturas\deck\02-tablero.png">    </p:cNvPr>
+          <p:cNvPr id="5" name="Image 0" descr="02-tablero.png">    </p:cNvPr>
           <p:cNvPicPr>
             <a:picLocks noChangeAspect="1"/>
           </p:cNvPicPr>
@@ -8491,7 +8491,7 @@
       </p:sp>
       <p:pic>
         <p:nvPicPr>
-          <p:cNvPr id="5" name="Image 0" descr="C:\Users\lucac\Documents\Aplicaciones\fieldops-modernization\docs\capturas\deck\03-tablero-oscuro.png">    </p:cNvPr>
+          <p:cNvPr id="5" name="Image 0" descr="03-tablero-oscuro.png">    </p:cNvPr>
           <p:cNvPicPr>
             <a:picLocks noChangeAspect="1"/>
           </p:cNvPicPr>
@@ -8659,7 +8659,7 @@
       </p:sp>
       <p:pic>
         <p:nvPicPr>
-          <p:cNvPr id="5" name="Image 0" descr="C:\Users\lucac\Documents\Aplicaciones\fieldops-modernization\docs\capturas\deck\04-tareas-kanban.png">    </p:cNvPr>
+          <p:cNvPr id="5" name="Image 0" descr="04-tareas-kanban.png">    </p:cNvPr>
           <p:cNvPicPr>
             <a:picLocks noChangeAspect="1"/>
           </p:cNvPicPr>
@@ -9151,7 +9151,7 @@
       </p:sp>
       <p:pic>
         <p:nvPicPr>
-          <p:cNvPr id="5" name="Image 0" descr="C:\Users\lucac\Documents\Aplicaciones\fieldops-modernization\docs\capturas\deck\14-tarea-detalle.png">    </p:cNvPr>
+          <p:cNvPr id="5" name="Image 0" descr="14-tarea-detalle.png">    </p:cNvPr>
           <p:cNvPicPr>
             <a:picLocks noChangeAspect="1"/>
           </p:cNvPicPr>
@@ -9319,7 +9319,7 @@
       </p:sp>
       <p:pic>
         <p:nvPicPr>
-          <p:cNvPr id="5" name="Image 0" descr="C:\Users\lucac\Documents\Aplicaciones\fieldops-modernization\docs\capturas\deck\05-stock.png">    </p:cNvPr>
+          <p:cNvPr id="5" name="Image 0" descr="05-stock.png">    </p:cNvPr>
           <p:cNvPicPr>
             <a:picLocks noChangeAspect="1"/>
           </p:cNvPicPr>
@@ -9377,7 +9377,7 @@
       </p:sp>
       <p:pic>
         <p:nvPicPr>
-          <p:cNvPr id="7" name="Image 1" descr="C:\Users\lucac\Documents\Aplicaciones\fieldops-modernization\docs\capturas\deck\06-altas.png">    </p:cNvPr>
+          <p:cNvPr id="7" name="Image 1" descr="06-altas.png">    </p:cNvPr>
           <p:cNvPicPr>
             <a:picLocks noChangeAspect="1"/>
           </p:cNvPicPr>

</xml_diff>